<commit_message>
Mengengeruest-PPTX auf Mappe10.xlsx aktualisiert + Umlaute
- Echte Zahlen aus der Stichwoche April 2026 (n=1.094) statt
  Schaetzwerte: Funnel mit 1.094 -> 1.030 -> 994 -> 891 -> 646
  Automatisierungs-Kandidaten (59 %).
- Phasen-Aufteilung: Phase 1 = 646 (59 %), Phase 2 = 245 (22 %),
  Phase 3/Sonstige = 203 (19 %); Phase-2-Gruende neu gewichtet
  (MV fehlt 35 %, unvollstaendig 33 %, kein Anhang 29 %).
- Top-10-Pools auf reale Auto-Kandidaten-Verteilung umgestellt
  (JDC 33 %, Fonds Finanz 12 %, blau direkt 10 %, ...);
  Top 3 = 54 %, Top 10 = 74 %.
- Jahres-Hochrechnung auf den tatsaechlichen Stichwochen-Umfang
  reskaliert (~57.000 statt 260.000 p.a.).
- Auf der Slide werden Umlaute (ae/oe/ue/ss -> a/o/u/ss mit Diakritika
  bzw. ss) korrekt geschrieben.
- Page-Version 10.69 -> 10.70.

https://claude.ai/code/session_012py3yuzrrWzzJ6cLiqCzZU
</commit_message>
<xml_diff>
--- a/Auswertung-BUe-Stichwoche-Vorschlag.pptx
+++ b/Auswertung-BUe-Stichwoche-Vorschlag.pptx
@@ -3135,7 +3135,7 @@
                 </a:solidFill>
                 <a:latin typeface="Calibri"/>
               </a:rPr>
-              <a:t>Automatisierungs-Potenzial Bestandsuebertragung ERGO   |   Stichwoche April 2026   |   ca. 5.000 Mails analysiert</a:t>
+              <a:t>Automatisierungs-Potenzial Bestandsübertragung ERGO   |   Stichwoche April 2026   |   1.094 Mails analysiert</a:t>
             </a:r>
           </a:p>
         </p:txBody>
@@ -3187,7 +3187,7 @@
                 </a:solidFill>
                 <a:latin typeface="Calibri"/>
               </a:rPr>
-              <a:t>▶  Kernaussage: 65 % der Mails sind regelbasiert automatisierbare BUe-Neuanfragen → rund 170.000 Vorgaenge p.a.</a:t>
+              <a:t>▶  Kernaussage: 59 % der Mails sind regelbasiert automatisierbare BÜ-Erstvorgänge mit vollständiger MV  →  646 von 1.094 Mails in einer einzigen Stichwoche.</a:t>
             </a:r>
           </a:p>
         </p:txBody>
@@ -3225,7 +3225,7 @@
                 </a:solidFill>
                 <a:latin typeface="Calibri"/>
               </a:rPr>
-              <a:t>FUNNEL: Vom Eingang zum Automatisierungs-Kandidat</a:t>
+              <a:t>FUNNEL: Vom Eingang zum Automatisierungs-Kandidaten</a:t>
             </a:r>
           </a:p>
         </p:txBody>
@@ -3279,7 +3279,7 @@
                 </a:solidFill>
                 <a:latin typeface="Calibri"/>
               </a:rPr>
-              <a:t>ca. 5.000   </a:t>
+              <a:t>1.094   </a:t>
             </a:r>
             <a:r>
               <a:rPr sz="1000" i="0">
@@ -3351,7 +3351,7 @@
                 </a:solidFill>
                 <a:latin typeface="Calibri"/>
               </a:rPr>
-              <a:t>– 6 %   </a:t>
+              <a:t>– 64   </a:t>
             </a:r>
             <a:r>
               <a:rPr sz="900" i="1">
@@ -3360,7 +3360,7 @@
                 </a:solidFill>
                 <a:latin typeface="Calibri"/>
               </a:rPr>
-              <a:t>Rauschen (Bounce / System / Werbung)</a:t>
+              <a:t>Rauschen (Bounce-NDR, System, ERGO-Outbound)</a:t>
             </a:r>
           </a:p>
         </p:txBody>
@@ -3414,7 +3414,7 @@
                 </a:solidFill>
                 <a:latin typeface="Calibri"/>
               </a:rPr>
-              <a:t>ca. 4.700   </a:t>
+              <a:t>1.030   </a:t>
             </a:r>
             <a:r>
               <a:rPr sz="1000" i="0">
@@ -3423,7 +3423,7 @@
                 </a:solidFill>
                 <a:latin typeface="Calibri"/>
               </a:rPr>
-              <a:t>Echte Makler-Vorgaenge</a:t>
+              <a:t>Echte Makler-Vorgänge</a:t>
             </a:r>
             <a:r>
               <a:rPr sz="1100" b="1">
@@ -3486,7 +3486,7 @@
                 </a:solidFill>
                 <a:latin typeface="Calibri"/>
               </a:rPr>
-              <a:t>– 4 %   </a:t>
+              <a:t>– 36   </a:t>
             </a:r>
             <a:r>
               <a:rPr sz="900" i="1">
@@ -3495,7 +3495,7 @@
                 </a:solidFill>
                 <a:latin typeface="Calibri"/>
               </a:rPr>
-              <a:t>Andere Klassifikation (Anfrage / Antrag)</a:t>
+              <a:t>Andere Klassifikation (Antrag, Anfrage)</a:t>
             </a:r>
           </a:p>
         </p:txBody>
@@ -3549,7 +3549,7 @@
                 </a:solidFill>
                 <a:latin typeface="Calibri"/>
               </a:rPr>
-              <a:t>ca. 4.500   </a:t>
+              <a:t>994   </a:t>
             </a:r>
             <a:r>
               <a:rPr sz="1000" i="0">
@@ -3558,7 +3558,7 @@
                 </a:solidFill>
                 <a:latin typeface="Calibri"/>
               </a:rPr>
-              <a:t>BUe-Vorgaenge</a:t>
+              <a:t>BÜ-Vorgänge</a:t>
             </a:r>
             <a:r>
               <a:rPr sz="1100" b="1">
@@ -3567,7 +3567,7 @@
                 </a:solidFill>
                 <a:latin typeface="Calibri"/>
               </a:rPr>
-              <a:t>    90 %</a:t>
+              <a:t>    91 %</a:t>
             </a:r>
           </a:p>
         </p:txBody>
@@ -3621,7 +3621,7 @@
                 </a:solidFill>
                 <a:latin typeface="Calibri"/>
               </a:rPr>
-              <a:t>– 7 %   </a:t>
+              <a:t>– 103   </a:t>
             </a:r>
             <a:r>
               <a:rPr sz="900" i="1">
@@ -3684,7 +3684,7 @@
                 </a:solidFill>
                 <a:latin typeface="Calibri"/>
               </a:rPr>
-              <a:t>ca. 4.150   </a:t>
+              <a:t>891   </a:t>
             </a:r>
             <a:r>
               <a:rPr sz="1000" i="0">
@@ -3693,7 +3693,7 @@
                 </a:solidFill>
                 <a:latin typeface="Calibri"/>
               </a:rPr>
-              <a:t>BUe-Erstvorgaenge</a:t>
+              <a:t>BÜ-Erstvorgänge</a:t>
             </a:r>
             <a:r>
               <a:rPr sz="1100" b="1">
@@ -3702,7 +3702,7 @@
                 </a:solidFill>
                 <a:latin typeface="Calibri"/>
               </a:rPr>
-              <a:t>    83 %</a:t>
+              <a:t>    81 %</a:t>
             </a:r>
           </a:p>
         </p:txBody>
@@ -3756,7 +3756,7 @@
                 </a:solidFill>
                 <a:latin typeface="Calibri"/>
               </a:rPr>
-              <a:t>– 18 %   </a:t>
+              <a:t>– 245   </a:t>
             </a:r>
             <a:r>
               <a:rPr sz="900" i="1">
@@ -3765,7 +3765,7 @@
                 </a:solidFill>
                 <a:latin typeface="Calibri"/>
               </a:rPr>
-              <a:t>MV-Klaerungsbedarf</a:t>
+              <a:t>MV-Klärungsbedarf</a:t>
             </a:r>
           </a:p>
         </p:txBody>
@@ -3819,7 +3819,7 @@
                 </a:solidFill>
                 <a:latin typeface="Calibri"/>
               </a:rPr>
-              <a:t>ca. 3.250   </a:t>
+              <a:t>646   </a:t>
             </a:r>
             <a:r>
               <a:rPr sz="1000" i="0">
@@ -3837,7 +3837,7 @@
                 </a:solidFill>
                 <a:latin typeface="Calibri"/>
               </a:rPr>
-              <a:t>    65 %</a:t>
+              <a:t>    59 %</a:t>
             </a:r>
           </a:p>
         </p:txBody>
@@ -3879,7 +3879,7 @@
                 </a:solidFill>
                 <a:latin typeface="Calibri"/>
               </a:rPr>
-              <a:t>Definition Automatisierungs-Kandidat: vollstaendige Maklervollmacht + Erstvorgang + BUe-Klassifikation.</a:t>
+              <a:t>Definition Automatisierungs-Kandidat: BÜ-Vorgang + Erstvorgang (kein Reminder) + MV-Status OK.</a:t>
             </a:r>
           </a:p>
         </p:txBody>
@@ -3963,7 +3963,7 @@
                 </a:solidFill>
                 <a:latin typeface="Calibri"/>
               </a:rPr>
-              <a:t>PHASE 1   Sofort automatisierbar   65 %</a:t>
+              <a:t>PHASE 1   Sofort automatisierbar   59 %  (646)</a:t>
             </a:r>
           </a:p>
           <a:p>
@@ -3979,7 +3979,7 @@
                 </a:solidFill>
                 <a:latin typeface="Calibri"/>
               </a:rPr>
-              <a:t>Sparten: Komposit ~ 60 %  |  KV ~ 30 %  |  Leben ~ 20 %</a:t>
+              <a:t>Sparten: Komposit 53 %  |  KV 29 %  |  Leben 16 %</a:t>
             </a:r>
           </a:p>
           <a:p>
@@ -3995,7 +3995,7 @@
                 </a:solidFill>
                 <a:latin typeface="Calibri"/>
               </a:rPr>
-              <a:t>Geschaeftstyp: Einfacher Vertrag ~ 85 %  |  Kundenverbindung ~ 20 %</a:t>
+              <a:t>Geschäftstyp (BÜ): einfacher Vertrag 76 %  |  Kundenverbindung 24 %</a:t>
             </a:r>
           </a:p>
           <a:p>
@@ -4011,7 +4011,7 @@
                 </a:solidFill>
                 <a:latin typeface="Calibri"/>
               </a:rPr>
-              <a:t>Sonderfaelle: &lt; 1 %  (manuell ausgenommen)</a:t>
+              <a:t>Anhang-Qualität: 94 % Text-PDF (automatisch parsebar)</a:t>
             </a:r>
           </a:p>
           <a:p>
@@ -4027,7 +4027,7 @@
                 </a:solidFill>
                 <a:latin typeface="Calibri"/>
               </a:rPr>
-              <a:t>Pool-Konzentration: Top 3 Pools decken ~ 65 % ab</a:t>
+              <a:t>Pool-Konzentration: Top 3 Pools decken 54 % ab</a:t>
             </a:r>
           </a:p>
           <a:p>
@@ -4043,7 +4043,7 @@
                 </a:solidFill>
                 <a:latin typeface="Calibri"/>
               </a:rPr>
-              <a:t>→ Schnittstellen-Priorisierung</a:t>
+              <a:t>→ Schnittstellen-Priorisierung auf JDC, Fonds Finanz, blau direkt</a:t>
             </a:r>
           </a:p>
         </p:txBody>
@@ -4089,7 +4089,7 @@
                 </a:solidFill>
                 <a:latin typeface="Calibri"/>
               </a:rPr>
-              <a:t>PHASE 2   Klaerungsbedarf   ~ 18 %</a:t>
+              <a:t>PHASE 2   Klärungsbedarf   22 %  (245)</a:t>
             </a:r>
           </a:p>
           <a:p>
@@ -4105,7 +4105,7 @@
                 </a:solidFill>
                 <a:latin typeface="Calibri"/>
               </a:rPr>
-              <a:t>~ 1/3   MV unvollstaendig    →  Klaerungs-Template</a:t>
+              <a:t>35 %   MV fehlt im Anhang         →  Outbound: MV nachfordern</a:t>
             </a:r>
           </a:p>
           <a:p>
@@ -4121,7 +4121,7 @@
                 </a:solidFill>
                 <a:latin typeface="Calibri"/>
               </a:rPr>
-              <a:t>~ 1/3   kein Anhang          →  Outbound: MV nachfordern</a:t>
+              <a:t>33 %   MV unvollständig            →  Klärungs-Template</a:t>
             </a:r>
           </a:p>
           <a:p>
@@ -4137,7 +4137,7 @@
                 </a:solidFill>
                 <a:latin typeface="Calibri"/>
               </a:rPr>
-              <a:t>~ 1/3   MV fehlt im Anhang   →  Outbound: MV nachfordern</a:t>
+              <a:t>29 %   kein Anhang                  →  Outbound: MV nachfordern</a:t>
             </a:r>
           </a:p>
           <a:p>
@@ -4153,7 +4153,7 @@
                 </a:solidFill>
                 <a:latin typeface="Calibri"/>
               </a:rPr>
-              <a:t>&lt; 5 %   nicht pruefbar       →  manuelle Sichtung</a:t>
+              <a:t>4 %    nicht prüfbar (Scan/OCR)   →  manuelle Sichtung</a:t>
             </a:r>
           </a:p>
           <a:p>
@@ -4215,7 +4215,7 @@
                 </a:solidFill>
                 <a:latin typeface="Calibri"/>
               </a:rPr>
-              <a:t>Ausserhalb Scope   ~ 17 %</a:t>
+              <a:t>Außerhalb Scope   19 %  (203)</a:t>
             </a:r>
           </a:p>
           <a:p>
@@ -4231,7 +4231,7 @@
                 </a:solidFill>
                 <a:latin typeface="Calibri"/>
               </a:rPr>
-              <a:t>~ 7 %   Reminder / Wiedervorlage   →  eigener SLA-Use-Case</a:t>
+              <a:t>9 %   Reminder / Wiedervorlage   →  eigener SLA-Use-Case</a:t>
             </a:r>
           </a:p>
           <a:p>
@@ -4247,7 +4247,7 @@
                 </a:solidFill>
                 <a:latin typeface="Calibri"/>
               </a:rPr>
-              <a:t>~ 4 %   Nicht-BUe                  →  andere Pipeline</a:t>
+              <a:t>3 %   Nicht-BÜ (Anfrage, Antrag) →  andere Pipeline</a:t>
             </a:r>
           </a:p>
           <a:p>
@@ -4263,7 +4263,7 @@
                 </a:solidFill>
                 <a:latin typeface="Calibri"/>
               </a:rPr>
-              <a:t>~ 6 %   Rauschen                   →  Spam-Filter / NDR</a:t>
+              <a:t>6 %   Rauschen                    →  Spam-Filter / NDR</a:t>
             </a:r>
           </a:p>
           <a:p>
@@ -4279,7 +4279,7 @@
                 </a:solidFill>
                 <a:latin typeface="Calibri"/>
               </a:rPr>
-              <a:t>&lt; 1 %   Sonderfaelle                →  Konsortien manuell</a:t>
+              <a:t>5 %   Sondertarif / Flotte         →  Konsortien manuell</a:t>
             </a:r>
           </a:p>
         </p:txBody>
@@ -4317,7 +4317,7 @@
                 </a:solidFill>
                 <a:latin typeface="Calibri"/>
               </a:rPr>
-              <a:t>Top 10 Pools in Automatisierungs-Kandidaten</a:t>
+              <a:t>Top 10 Pools in Automatisierungs-Kandidaten (n = 646)</a:t>
             </a:r>
           </a:p>
         </p:txBody>
@@ -4331,7 +4331,7 @@
         <p:spPr>
           <a:xfrm>
             <a:off x="8686800" y="1463040"/>
-            <a:ext cx="1920240" cy="292608"/>
+            <a:ext cx="2194560" cy="292608"/>
           </a:xfrm>
           <a:prstGeom prst="rect">
             <a:avLst/>
@@ -4368,8 +4368,8 @@
         </p:nvSpPr>
         <p:spPr>
           <a:xfrm>
-            <a:off x="10607040" y="1527048"/>
-            <a:ext cx="807415" cy="164592"/>
+            <a:off x="10881360" y="1527048"/>
+            <a:ext cx="533095" cy="164592"/>
           </a:xfrm>
           <a:prstGeom prst="rect">
             <a:avLst/>
@@ -4411,8 +4411,8 @@
         </p:nvSpPr>
         <p:spPr>
           <a:xfrm>
-            <a:off x="10607040" y="1527048"/>
-            <a:ext cx="807415" cy="164592"/>
+            <a:off x="10881360" y="1527048"/>
+            <a:ext cx="533095" cy="164592"/>
           </a:xfrm>
           <a:prstGeom prst="rect">
             <a:avLst/>
@@ -4479,7 +4479,7 @@
                 </a:solidFill>
                 <a:latin typeface="Calibri"/>
               </a:rPr>
-              <a:t>ca. 40 %</a:t>
+              <a:t>33 %</a:t>
             </a:r>
           </a:p>
         </p:txBody>
@@ -4493,7 +4493,7 @@
         <p:spPr>
           <a:xfrm>
             <a:off x="8686800" y="1755648"/>
-            <a:ext cx="1920240" cy="292608"/>
+            <a:ext cx="2194560" cy="292608"/>
           </a:xfrm>
           <a:prstGeom prst="rect">
             <a:avLst/>
@@ -4530,8 +4530,8 @@
         </p:nvSpPr>
         <p:spPr>
           <a:xfrm>
-            <a:off x="10607040" y="1819656"/>
-            <a:ext cx="807415" cy="164592"/>
+            <a:off x="10881360" y="1819656"/>
+            <a:ext cx="533095" cy="164592"/>
           </a:xfrm>
           <a:prstGeom prst="rect">
             <a:avLst/>
@@ -4573,8 +4573,8 @@
         </p:nvSpPr>
         <p:spPr>
           <a:xfrm>
-            <a:off x="10607040" y="1819656"/>
-            <a:ext cx="363336" cy="164592"/>
+            <a:off x="10881360" y="1819656"/>
+            <a:ext cx="193852" cy="164592"/>
           </a:xfrm>
           <a:prstGeom prst="rect">
             <a:avLst/>
@@ -4641,7 +4641,7 @@
                 </a:solidFill>
                 <a:latin typeface="Calibri"/>
               </a:rPr>
-              <a:t>ca. 18 %</a:t>
+              <a:t>12 %</a:t>
             </a:r>
           </a:p>
         </p:txBody>
@@ -4655,7 +4655,7 @@
         <p:spPr>
           <a:xfrm>
             <a:off x="8686800" y="2048256"/>
-            <a:ext cx="1920240" cy="292608"/>
+            <a:ext cx="2194560" cy="292608"/>
           </a:xfrm>
           <a:prstGeom prst="rect">
             <a:avLst/>
@@ -4692,8 +4692,8 @@
         </p:nvSpPr>
         <p:spPr>
           <a:xfrm>
-            <a:off x="10607040" y="2112264"/>
-            <a:ext cx="807415" cy="164592"/>
+            <a:off x="10881360" y="2112264"/>
+            <a:ext cx="533095" cy="164592"/>
           </a:xfrm>
           <a:prstGeom prst="rect">
             <a:avLst/>
@@ -4735,8 +4735,8 @@
         </p:nvSpPr>
         <p:spPr>
           <a:xfrm>
-            <a:off x="10607040" y="2112264"/>
-            <a:ext cx="141297" cy="164592"/>
+            <a:off x="10881360" y="2112264"/>
+            <a:ext cx="161543" cy="164592"/>
           </a:xfrm>
           <a:prstGeom prst="rect">
             <a:avLst/>
@@ -4803,7 +4803,7 @@
                 </a:solidFill>
                 <a:latin typeface="Calibri"/>
               </a:rPr>
-              <a:t>ca. 7 %</a:t>
+              <a:t>10 %</a:t>
             </a:r>
           </a:p>
         </p:txBody>
@@ -4817,7 +4817,7 @@
         <p:spPr>
           <a:xfrm>
             <a:off x="8686800" y="2340864"/>
-            <a:ext cx="1920240" cy="292608"/>
+            <a:ext cx="2194560" cy="292608"/>
           </a:xfrm>
           <a:prstGeom prst="rect">
             <a:avLst/>
@@ -4841,7 +4841,7 @@
                 </a:solidFill>
                 <a:latin typeface="Calibri"/>
               </a:rPr>
-              <a:t>4.  DEMA</a:t>
+              <a:t>4.  DEMA Deutsche Versicherungsmakler</a:t>
             </a:r>
           </a:p>
         </p:txBody>
@@ -4854,8 +4854,8 @@
         </p:nvSpPr>
         <p:spPr>
           <a:xfrm>
-            <a:off x="10607040" y="2404872"/>
-            <a:ext cx="807415" cy="164592"/>
+            <a:off x="10881360" y="2404872"/>
+            <a:ext cx="533095" cy="164592"/>
           </a:xfrm>
           <a:prstGeom prst="rect">
             <a:avLst/>
@@ -4897,8 +4897,8 @@
         </p:nvSpPr>
         <p:spPr>
           <a:xfrm>
-            <a:off x="10607040" y="2404872"/>
-            <a:ext cx="60556" cy="164592"/>
+            <a:off x="10881360" y="2404872"/>
+            <a:ext cx="80771" cy="164592"/>
           </a:xfrm>
           <a:prstGeom prst="rect">
             <a:avLst/>
@@ -4965,7 +4965,7 @@
                 </a:solidFill>
                 <a:latin typeface="Calibri"/>
               </a:rPr>
-              <a:t>ca. 3 %</a:t>
+              <a:t>5 %</a:t>
             </a:r>
           </a:p>
         </p:txBody>
@@ -4979,7 +4979,7 @@
         <p:spPr>
           <a:xfrm>
             <a:off x="8686800" y="2633472"/>
-            <a:ext cx="1920240" cy="292608"/>
+            <a:ext cx="2194560" cy="292608"/>
           </a:xfrm>
           <a:prstGeom prst="rect">
             <a:avLst/>
@@ -5003,7 +5003,7 @@
                 </a:solidFill>
                 <a:latin typeface="Calibri"/>
               </a:rPr>
-              <a:t>5.  Securess Versicherungsmakler</a:t>
+              <a:t>5.  Fuhrmann Versicherungsmakler</a:t>
             </a:r>
           </a:p>
         </p:txBody>
@@ -5016,8 +5016,8 @@
         </p:nvSpPr>
         <p:spPr>
           <a:xfrm>
-            <a:off x="10607040" y="2697480"/>
-            <a:ext cx="807415" cy="164592"/>
+            <a:off x="10881360" y="2697480"/>
+            <a:ext cx="533095" cy="164592"/>
           </a:xfrm>
           <a:prstGeom prst="rect">
             <a:avLst/>
@@ -5059,8 +5059,8 @@
         </p:nvSpPr>
         <p:spPr>
           <a:xfrm>
-            <a:off x="10607040" y="2697480"/>
-            <a:ext cx="40370" cy="164592"/>
+            <a:off x="10881360" y="2697480"/>
+            <a:ext cx="48463" cy="164592"/>
           </a:xfrm>
           <a:prstGeom prst="rect">
             <a:avLst/>
@@ -5127,7 +5127,7 @@
                 </a:solidFill>
                 <a:latin typeface="Calibri"/>
               </a:rPr>
-              <a:t>ca. 2 %</a:t>
+              <a:t>3 %</a:t>
             </a:r>
           </a:p>
         </p:txBody>
@@ -5141,7 +5141,7 @@
         <p:spPr>
           <a:xfrm>
             <a:off x="8686800" y="2926080"/>
-            <a:ext cx="1920240" cy="292608"/>
+            <a:ext cx="2194560" cy="292608"/>
           </a:xfrm>
           <a:prstGeom prst="rect">
             <a:avLst/>
@@ -5165,7 +5165,7 @@
                 </a:solidFill>
                 <a:latin typeface="Calibri"/>
               </a:rPr>
-              <a:t>6.  1:1 Assekuranzservice</a:t>
+              <a:t>6.  Qualitypool</a:t>
             </a:r>
           </a:p>
         </p:txBody>
@@ -5178,8 +5178,8 @@
         </p:nvSpPr>
         <p:spPr>
           <a:xfrm>
-            <a:off x="10607040" y="2990088"/>
-            <a:ext cx="807415" cy="164592"/>
+            <a:off x="10881360" y="2990088"/>
+            <a:ext cx="533095" cy="164592"/>
           </a:xfrm>
           <a:prstGeom prst="rect">
             <a:avLst/>
@@ -5221,8 +5221,8 @@
         </p:nvSpPr>
         <p:spPr>
           <a:xfrm>
-            <a:off x="10607040" y="2990088"/>
-            <a:ext cx="40370" cy="164592"/>
+            <a:off x="10881360" y="2990088"/>
+            <a:ext cx="48463" cy="164592"/>
           </a:xfrm>
           <a:prstGeom prst="rect">
             <a:avLst/>
@@ -5289,7 +5289,7 @@
                 </a:solidFill>
                 <a:latin typeface="Calibri"/>
               </a:rPr>
-              <a:t>ca. 2 %</a:t>
+              <a:t>3 %</a:t>
             </a:r>
           </a:p>
         </p:txBody>
@@ -5303,7 +5303,7 @@
         <p:spPr>
           <a:xfrm>
             <a:off x="8686800" y="3218688"/>
-            <a:ext cx="1920240" cy="292608"/>
+            <a:ext cx="2194560" cy="292608"/>
           </a:xfrm>
           <a:prstGeom prst="rect">
             <a:avLst/>
@@ -5327,7 +5327,7 @@
                 </a:solidFill>
                 <a:latin typeface="Calibri"/>
               </a:rPr>
-              <a:t>7.  [pma:] Finanz-Service</a:t>
+              <a:t>7.  Securess Versicherungsmakler</a:t>
             </a:r>
           </a:p>
         </p:txBody>
@@ -5340,8 +5340,8 @@
         </p:nvSpPr>
         <p:spPr>
           <a:xfrm>
-            <a:off x="10607040" y="3282696"/>
-            <a:ext cx="807415" cy="164592"/>
+            <a:off x="10881360" y="3282696"/>
+            <a:ext cx="533095" cy="164592"/>
           </a:xfrm>
           <a:prstGeom prst="rect">
             <a:avLst/>
@@ -5383,8 +5383,8 @@
         </p:nvSpPr>
         <p:spPr>
           <a:xfrm>
-            <a:off x="10607040" y="3282696"/>
-            <a:ext cx="20185" cy="164592"/>
+            <a:off x="10881360" y="3282696"/>
+            <a:ext cx="32308" cy="164592"/>
           </a:xfrm>
           <a:prstGeom prst="rect">
             <a:avLst/>
@@ -5451,7 +5451,7 @@
                 </a:solidFill>
                 <a:latin typeface="Calibri"/>
               </a:rPr>
-              <a:t>ca. 1 %</a:t>
+              <a:t>2 %</a:t>
             </a:r>
           </a:p>
         </p:txBody>
@@ -5465,7 +5465,7 @@
         <p:spPr>
           <a:xfrm>
             <a:off x="8686800" y="3511296"/>
-            <a:ext cx="1920240" cy="292608"/>
+            <a:ext cx="2194560" cy="292608"/>
           </a:xfrm>
           <a:prstGeom prst="rect">
             <a:avLst/>
@@ -5489,7 +5489,7 @@
                 </a:solidFill>
                 <a:latin typeface="Calibri"/>
               </a:rPr>
-              <a:t>8.  Qualitypool</a:t>
+              <a:t>8.  [pma:] Finanz-Service</a:t>
             </a:r>
           </a:p>
         </p:txBody>
@@ -5502,8 +5502,8 @@
         </p:nvSpPr>
         <p:spPr>
           <a:xfrm>
-            <a:off x="10607040" y="3575304"/>
-            <a:ext cx="807415" cy="164592"/>
+            <a:off x="10881360" y="3575304"/>
+            <a:ext cx="533095" cy="164592"/>
           </a:xfrm>
           <a:prstGeom prst="rect">
             <a:avLst/>
@@ -5545,8 +5545,8 @@
         </p:nvSpPr>
         <p:spPr>
           <a:xfrm>
-            <a:off x="10607040" y="3575304"/>
-            <a:ext cx="20185" cy="164592"/>
+            <a:off x="10881360" y="3575304"/>
+            <a:ext cx="32308" cy="164592"/>
           </a:xfrm>
           <a:prstGeom prst="rect">
             <a:avLst/>
@@ -5613,7 +5613,7 @@
                 </a:solidFill>
                 <a:latin typeface="Calibri"/>
               </a:rPr>
-              <a:t>ca. 1 %</a:t>
+              <a:t>2 %</a:t>
             </a:r>
           </a:p>
         </p:txBody>
@@ -5627,7 +5627,7 @@
         <p:spPr>
           <a:xfrm>
             <a:off x="8686800" y="3803904"/>
-            <a:ext cx="1920240" cy="292608"/>
+            <a:ext cx="2194560" cy="292608"/>
           </a:xfrm>
           <a:prstGeom prst="rect">
             <a:avLst/>
@@ -5651,7 +5651,7 @@
                 </a:solidFill>
                 <a:latin typeface="Calibri"/>
               </a:rPr>
-              <a:t>9.  Invers GmbH</a:t>
+              <a:t>9.  Apella AG</a:t>
             </a:r>
           </a:p>
         </p:txBody>
@@ -5664,8 +5664,8 @@
         </p:nvSpPr>
         <p:spPr>
           <a:xfrm>
-            <a:off x="10607040" y="3867912"/>
-            <a:ext cx="807415" cy="164592"/>
+            <a:off x="10881360" y="3867912"/>
+            <a:ext cx="533095" cy="164592"/>
           </a:xfrm>
           <a:prstGeom prst="rect">
             <a:avLst/>
@@ -5707,8 +5707,8 @@
         </p:nvSpPr>
         <p:spPr>
           <a:xfrm>
-            <a:off x="10607040" y="3867912"/>
-            <a:ext cx="20185" cy="164592"/>
+            <a:off x="10881360" y="3867912"/>
+            <a:ext cx="32308" cy="164592"/>
           </a:xfrm>
           <a:prstGeom prst="rect">
             <a:avLst/>
@@ -5775,7 +5775,7 @@
                 </a:solidFill>
                 <a:latin typeface="Calibri"/>
               </a:rPr>
-              <a:t>ca. 1 %</a:t>
+              <a:t>2 %</a:t>
             </a:r>
           </a:p>
         </p:txBody>
@@ -5789,7 +5789,7 @@
         <p:spPr>
           <a:xfrm>
             <a:off x="8686800" y="4096512"/>
-            <a:ext cx="1920240" cy="292608"/>
+            <a:ext cx="2194560" cy="292608"/>
           </a:xfrm>
           <a:prstGeom prst="rect">
             <a:avLst/>
@@ -5813,7 +5813,7 @@
                 </a:solidFill>
                 <a:latin typeface="Calibri"/>
               </a:rPr>
-              <a:t>10. Apella AG</a:t>
+              <a:t>10. TauRes Gesellschaft für Investmentberatung</a:t>
             </a:r>
           </a:p>
         </p:txBody>
@@ -5826,8 +5826,8 @@
         </p:nvSpPr>
         <p:spPr>
           <a:xfrm>
-            <a:off x="10607040" y="4160520"/>
-            <a:ext cx="807415" cy="164592"/>
+            <a:off x="10881360" y="4160520"/>
+            <a:ext cx="533095" cy="164592"/>
           </a:xfrm>
           <a:prstGeom prst="rect">
             <a:avLst/>
@@ -5869,8 +5869,8 @@
         </p:nvSpPr>
         <p:spPr>
           <a:xfrm>
-            <a:off x="10607040" y="4160520"/>
-            <a:ext cx="20185" cy="164592"/>
+            <a:off x="10881360" y="4160520"/>
+            <a:ext cx="32308" cy="164592"/>
           </a:xfrm>
           <a:prstGeom prst="rect">
             <a:avLst/>
@@ -5937,7 +5937,7 @@
                 </a:solidFill>
                 <a:latin typeface="Calibri"/>
               </a:rPr>
-              <a:t>ca. 1 %</a:t>
+              <a:t>2 %</a:t>
             </a:r>
           </a:p>
         </p:txBody>
@@ -5979,7 +5979,7 @@
                 </a:solidFill>
                 <a:latin typeface="Calibri"/>
               </a:rPr>
-              <a:t>Top 10 zusammen ca. 75 %  |  Long Tail (100+ Pools) ca. 25 %</a:t>
+              <a:t>Top 3 = 54 %   |   Top 10 = 74 %   |   Long Tail (90+ Pools) = 26 %</a:t>
             </a:r>
           </a:p>
         </p:txBody>
@@ -6025,7 +6025,7 @@
                 </a:solidFill>
                 <a:latin typeface="Calibri"/>
               </a:rPr>
-              <a:t>Hochrechnung auf das Jahr (annahmegestuetzt)</a:t>
+              <a:t>Hochrechnung auf das Jahr (1.094 Mails × ca. 52 Wochen)</a:t>
             </a:r>
           </a:p>
           <a:p>
@@ -6041,7 +6041,7 @@
                 </a:solidFill>
                 <a:latin typeface="Calibri"/>
               </a:rPr>
-              <a:t>ca. 170.000   Phase 1   Automatisierungs-Potenzial</a:t>
+              <a:t>ca. 33.600   Phase 1   Automatisierungs-Potenzial</a:t>
             </a:r>
           </a:p>
           <a:p>
@@ -6057,7 +6057,7 @@
                 </a:solidFill>
                 <a:latin typeface="Calibri"/>
               </a:rPr>
-              <a:t>ca.  45.000   Phase 2   Halbautomatische Klaerung</a:t>
+              <a:t>ca. 12.700   Phase 2   Halbautomatische MV-Klärung</a:t>
             </a:r>
           </a:p>
           <a:p>
@@ -6073,7 +6073,7 @@
                 </a:solidFill>
                 <a:latin typeface="Calibri"/>
               </a:rPr>
-              <a:t>ca.  18.000   Phase 3   Reminder- / SLA-Logik</a:t>
+              <a:t>ca.  5.400   Phase 3   Reminder- / SLA-Logik</a:t>
             </a:r>
           </a:p>
           <a:p>
@@ -6089,7 +6089,7 @@
                 </a:solidFill>
                 <a:latin typeface="Calibri"/>
               </a:rPr>
-              <a:t>ca.  10.000   Manuell   Sonstige + Eskalationen</a:t>
+              <a:t>ca.  1.900             Andere Klassifikation (Antrag, Anfrage)</a:t>
             </a:r>
           </a:p>
           <a:p>
@@ -6105,7 +6105,7 @@
                 </a:solidFill>
                 <a:latin typeface="Calibri"/>
               </a:rPr>
-              <a:t>ca.  15.000   Rauschen  (NDR / Spam-Filter)</a:t>
+              <a:t>ca.  3.300             Rauschen (NDR, System, Outbound)</a:t>
             </a:r>
           </a:p>
           <a:p>
@@ -6121,7 +6121,7 @@
                 </a:solidFill>
                 <a:latin typeface="Calibri"/>
               </a:rPr>
-              <a:t>ca. 260.000   GESAMT-Mails p.a. im SHUK-Innendienst</a:t>
+              <a:t>ca. 56.900   GESAMT-Mails p.a. im SHUK-Innendienst (Hochrechnung)</a:t>
             </a:r>
           </a:p>
         </p:txBody>
@@ -6183,7 +6183,7 @@
                 </a:solidFill>
                 <a:latin typeface="Calibri"/>
               </a:rPr>
-              <a:t>Phase-1-Pilot mit Top 3 Pools (JDC, Fonds Finanz, blau direkt) deckt mit nur DREI Schnittstellen rund zwei Drittel des Automatisierungs-Potenzials ab.</a:t>
+              <a:t>Phase-1-Pilot mit Top 3 Pools (JDC, Fonds Finanz, blau direkt) deckt mit nur DREI Schnittstellen rund 54 % des Automatisierungs-Potenzials ab — Top 10 decken 74 %.</a:t>
             </a:r>
           </a:p>
           <a:p>
@@ -6215,7 +6215,7 @@
                 </a:solidFill>
                 <a:latin typeface="Calibri"/>
               </a:rPr>
-              <a:t>Folge-Phasen: MV-Klaerungs-Templates fuer Top 3 Klaerungsgruende → +18 % Volumen mit halbautomatischem Workflow.</a:t>
+              <a:t>Folge-Phase: MV-Klärungs-Templates für die drei Hauptgründe (MV fehlt, MV unvollständig, kein Anhang) → +22 % Volumen halbautomatisch.</a:t>
             </a:r>
           </a:p>
         </p:txBody>
@@ -6253,7 +6253,7 @@
                 </a:solidFill>
                 <a:latin typeface="Calibri"/>
               </a:rPr>
-              <a:t>Datenquelle: ergo-vorgang-analyse.hta v1.62 | KI-gestuetzte Klassifikation Mail + PDF-Anhang | Pool-Schreibweisen konsolidiert | Eine Stichwoche, keine Saisonalitaet beruecksichtigt</a:t>
+              <a:t>Datenquelle: Mappe10.xlsx — ergo-vorgang-analyse v2.13  |  KI-Klassifikation Mail + PDF-Anhang  |  Pool-Schreibweisen konsolidiert  |  Eine Stichwoche, keine Saisonalität berücksichtigt</a:t>
             </a:r>
           </a:p>
         </p:txBody>

</xml_diff>